<commit_message>
Prezentacja v4: slajdy 25-27 jako rzut z góry setu z kamerą
Co-Authored-By: Claude Sonnet 5.5 <noreply@anthropic.com>
Claude-Session: https://claude.ai/code/session_01RxET8S5NWKo13oo2mh7L1U
</commit_message>
<xml_diff>
--- a/projekty/warsztaty-beauty-product/swiatlo-jako-narzedzie-pracy-v4.pptx
+++ b/projekty/warsztaty-beauty-product/swiatlo-jako-narzedzie-pracy-v4.pptx
@@ -26191,35 +26191,27 @@
           </a:p>
         </p:txBody>
       </p:sp>
-      <p:sp>
-        <p:nvSpPr>
-          <p:cNvPr id="101" name="Element 101"/>
-          <p:cNvSpPr/>
-          <p:nvPr/>
-        </p:nvSpPr>
-        <p:spPr>
-          <a:xfrm>
-            <a:off x="7223760" y="3840480"/>
-            <a:ext cx="2743200" cy="1371600"/>
-          </a:xfrm>
-          <a:prstGeom prst="round2SameRect">
-            <a:avLst/>
-          </a:prstGeom>
-          <a:noFill/>
-          <a:ln w="22225">
+      <p:cxnSp>
+        <p:nvCxnSpPr>
+          <p:cNvPr id="101" name="Linia 101"/>
+          <p:cNvCxnSpPr/>
+          <p:nvPr/>
+        </p:nvCxnSpPr>
+        <p:spPr>
+          <a:xfrm>
+            <a:off x="6217920" y="1554480"/>
+            <a:ext cx="4754880" cy="0"/>
+          </a:xfrm>
+          <a:prstGeom prst="line">
+            <a:avLst/>
+          </a:prstGeom>
+          <a:ln w="38100">
             <a:solidFill>
               <a:srgbClr val="404040"/>
             </a:solidFill>
           </a:ln>
         </p:spPr>
-        <p:txBody>
-          <a:bodyPr/>
-          <a:lstStyle/>
-          <a:p>
-            <a:endParaRPr lang="pl-PL"/>
-          </a:p>
-        </p:txBody>
-      </p:sp>
+      </p:cxnSp>
       <p:sp>
         <p:nvSpPr>
           <p:cNvPr id="102" name="Element 102"/>
@@ -26228,137 +26220,8 @@
         </p:nvSpPr>
         <p:spPr>
           <a:xfrm>
-            <a:off x="7680960" y="1828800"/>
-            <a:ext cx="1828800" cy="1828800"/>
-          </a:xfrm>
-          <a:prstGeom prst="pie">
-            <a:avLst>
-              <a:gd name="adj1" fmla="val 5400000"/>
-              <a:gd name="adj2" fmla="val 16200000"/>
-            </a:avLst>
-          </a:prstGeom>
-          <a:solidFill>
-            <a:srgbClr val="E3B18D">
-              <a:alpha val="55000"/>
-            </a:srgbClr>
-          </a:solidFill>
-          <a:ln>
-            <a:noFill/>
-          </a:ln>
-        </p:spPr>
-        <p:txBody>
-          <a:bodyPr/>
-          <a:lstStyle/>
-          <a:p>
-            <a:endParaRPr lang="pl-PL"/>
-          </a:p>
-        </p:txBody>
-      </p:sp>
-      <p:sp>
-        <p:nvSpPr>
-          <p:cNvPr id="103" name="Element 103"/>
-          <p:cNvSpPr/>
-          <p:nvPr/>
-        </p:nvSpPr>
-        <p:spPr>
-          <a:xfrm>
-            <a:off x="7680960" y="1828800"/>
-            <a:ext cx="1828800" cy="1828800"/>
-          </a:xfrm>
-          <a:prstGeom prst="pie">
-            <a:avLst>
-              <a:gd name="adj1" fmla="val 16200000"/>
-              <a:gd name="adj2" fmla="val 5400000"/>
-            </a:avLst>
-          </a:prstGeom>
-          <a:solidFill>
-            <a:srgbClr val="404040">
-              <a:alpha val="30000"/>
-            </a:srgbClr>
-          </a:solidFill>
-          <a:ln>
-            <a:noFill/>
-          </a:ln>
-        </p:spPr>
-        <p:txBody>
-          <a:bodyPr/>
-          <a:lstStyle/>
-          <a:p>
-            <a:endParaRPr lang="pl-PL"/>
-          </a:p>
-        </p:txBody>
-      </p:sp>
-      <p:sp>
-        <p:nvSpPr>
-          <p:cNvPr id="104" name="Element 104"/>
-          <p:cNvSpPr/>
-          <p:nvPr/>
-        </p:nvSpPr>
-        <p:spPr>
-          <a:xfrm>
-            <a:off x="7680960" y="1828800"/>
-            <a:ext cx="1828800" cy="1828800"/>
-          </a:xfrm>
-          <a:prstGeom prst="ellipse">
-            <a:avLst/>
-          </a:prstGeom>
-          <a:noFill/>
-          <a:ln w="22225">
-            <a:solidFill>
-              <a:srgbClr val="404040"/>
-            </a:solidFill>
-          </a:ln>
-        </p:spPr>
-        <p:txBody>
-          <a:bodyPr/>
-          <a:lstStyle/>
-          <a:p>
-            <a:endParaRPr lang="pl-PL"/>
-          </a:p>
-        </p:txBody>
-      </p:sp>
-      <p:sp>
-        <p:nvSpPr>
-          <p:cNvPr id="105" name="Element 105"/>
-          <p:cNvSpPr/>
-          <p:nvPr/>
-        </p:nvSpPr>
-        <p:spPr>
-          <a:xfrm>
-            <a:off x="7607808" y="1755648"/>
-            <a:ext cx="1975104" cy="1975104"/>
-          </a:xfrm>
-          <a:prstGeom prst="arc">
-            <a:avLst>
-              <a:gd name="adj1" fmla="val 18000000"/>
-              <a:gd name="adj2" fmla="val 3600000"/>
-            </a:avLst>
-          </a:prstGeom>
-          <a:noFill/>
-          <a:ln w="63500">
-            <a:solidFill>
-              <a:srgbClr val="E3B18D"/>
-            </a:solidFill>
-          </a:ln>
-        </p:spPr>
-        <p:txBody>
-          <a:bodyPr/>
-          <a:lstStyle/>
-          <a:p>
-            <a:endParaRPr lang="pl-PL"/>
-          </a:p>
-        </p:txBody>
-      </p:sp>
-      <p:sp>
-        <p:nvSpPr>
-          <p:cNvPr id="106" name="Element 106"/>
-          <p:cNvSpPr/>
-          <p:nvPr/>
-        </p:nvSpPr>
-        <p:spPr>
-          <a:xfrm>
-            <a:off x="5577840" y="2560320"/>
-            <a:ext cx="1463040" cy="365760"/>
+            <a:off x="9692640" y="1143000"/>
+            <a:ext cx="1280160" cy="320040"/>
           </a:xfrm>
           <a:prstGeom prst="rect">
             <a:avLst/>
@@ -26376,150 +26239,32 @@
           <a:p>
             <a:pPr algn="r"/>
             <a:r>
-              <a:rPr lang="pl-PL" sz="1800" b="1" dirty="0">
-                <a:solidFill>
-                  <a:srgbClr val="404040"/>
+              <a:rPr lang="pl-PL" sz="1400" b="0" dirty="0">
+                <a:solidFill>
+                  <a:srgbClr val="8A8A8A"/>
                 </a:solidFill>
                 <a:latin typeface="+mn-lt"/>
               </a:rPr>
-              <a:t>key</a:t>
+              <a:t>tło</a:t>
             </a:r>
           </a:p>
         </p:txBody>
       </p:sp>
       <p:cxnSp>
         <p:nvCxnSpPr>
-          <p:cNvPr id="107" name="Linia 107"/>
+          <p:cNvPr id="103" name="Linia 103"/>
           <p:cNvCxnSpPr/>
           <p:nvPr/>
         </p:nvCxnSpPr>
         <p:spPr>
           <a:xfrm>
-            <a:off x="7132320" y="2743200"/>
-            <a:ext cx="411480" cy="0"/>
+            <a:off x="7223760" y="1737360"/>
+            <a:ext cx="1143000" cy="3520440"/>
           </a:xfrm>
           <a:prstGeom prst="line">
             <a:avLst/>
           </a:prstGeom>
-          <a:ln w="15875">
-            <a:solidFill>
-              <a:srgbClr val="E3B18D"/>
-            </a:solidFill>
-          </a:ln>
-        </p:spPr>
-      </p:cxnSp>
-      <p:sp>
-        <p:nvSpPr>
-          <p:cNvPr id="108" name="Element 108"/>
-          <p:cNvSpPr/>
-          <p:nvPr/>
-        </p:nvSpPr>
-        <p:spPr>
-          <a:xfrm>
-            <a:off x="9875520" y="1828800"/>
-            <a:ext cx="1645920" cy="365760"/>
-          </a:xfrm>
-          <a:prstGeom prst="rect">
-            <a:avLst/>
-          </a:prstGeom>
-          <a:noFill/>
-          <a:ln>
-            <a:noFill/>
-          </a:ln>
-        </p:spPr>
-        <p:txBody>
-          <a:bodyPr wrap="square" lIns="0" tIns="0" rIns="0" bIns="0" anchor="ctr">
-            <a:noAutofit/>
-          </a:bodyPr>
-          <a:lstStyle/>
-          <a:p>
-            <a:pPr algn="l"/>
-            <a:r>
-              <a:rPr lang="pl-PL" sz="1800" b="1" dirty="0">
-                <a:solidFill>
-                  <a:srgbClr val="404040"/>
-                </a:solidFill>
-                <a:latin typeface="+mn-lt"/>
-              </a:rPr>
-              <a:t>rim</a:t>
-            </a:r>
-          </a:p>
-        </p:txBody>
-      </p:sp>
-      <p:cxnSp>
-        <p:nvCxnSpPr>
-          <p:cNvPr id="109" name="Linia 109"/>
-          <p:cNvCxnSpPr/>
-          <p:nvPr/>
-        </p:nvCxnSpPr>
-        <p:spPr>
-          <a:xfrm>
-            <a:off x="9601200" y="2011680"/>
-            <a:ext cx="274320" cy="0"/>
-          </a:xfrm>
-          <a:prstGeom prst="line">
-            <a:avLst/>
-          </a:prstGeom>
-          <a:ln w="15875">
-            <a:solidFill>
-              <a:srgbClr val="E3B18D"/>
-            </a:solidFill>
-          </a:ln>
-        </p:spPr>
-      </p:cxnSp>
-      <p:sp>
-        <p:nvSpPr>
-          <p:cNvPr id="110" name="Element 110"/>
-          <p:cNvSpPr/>
-          <p:nvPr/>
-        </p:nvSpPr>
-        <p:spPr>
-          <a:xfrm>
-            <a:off x="9875520" y="3017520"/>
-            <a:ext cx="1645920" cy="365760"/>
-          </a:xfrm>
-          <a:prstGeom prst="rect">
-            <a:avLst/>
-          </a:prstGeom>
-          <a:noFill/>
-          <a:ln>
-            <a:noFill/>
-          </a:ln>
-        </p:spPr>
-        <p:txBody>
-          <a:bodyPr wrap="square" lIns="0" tIns="0" rIns="0" bIns="0" anchor="ctr">
-            <a:noAutofit/>
-          </a:bodyPr>
-          <a:lstStyle/>
-          <a:p>
-            <a:pPr algn="l"/>
-            <a:r>
-              <a:rPr lang="pl-PL" sz="1800" b="1" dirty="0">
-                <a:solidFill>
-                  <a:srgbClr val="404040"/>
-                </a:solidFill>
-                <a:latin typeface="+mn-lt"/>
-              </a:rPr>
-              <a:t>fill</a:t>
-            </a:r>
-          </a:p>
-        </p:txBody>
-      </p:sp>
-      <p:cxnSp>
-        <p:nvCxnSpPr>
-          <p:cNvPr id="111" name="Linia 111"/>
-          <p:cNvCxnSpPr/>
-          <p:nvPr/>
-        </p:nvCxnSpPr>
-        <p:spPr>
-          <a:xfrm>
-            <a:off x="9052560" y="3108960"/>
-            <a:ext cx="822960" cy="91440"/>
-          </a:xfrm>
-          <a:prstGeom prst="line">
-            <a:avLst/>
-          </a:prstGeom>
-          <a:ln w="15875">
+          <a:ln w="12700">
             <a:solidFill>
               <a:srgbClr val="8A8A8A"/>
             </a:solidFill>
@@ -26527,6 +26272,422 @@
           </a:ln>
         </p:spPr>
       </p:cxnSp>
+      <p:cxnSp>
+        <p:nvCxnSpPr>
+          <p:cNvPr id="104" name="Linia 104"/>
+          <p:cNvCxnSpPr/>
+          <p:nvPr/>
+        </p:nvCxnSpPr>
+        <p:spPr>
+          <a:xfrm flipV="1">
+            <a:off x="8823960" y="1737360"/>
+            <a:ext cx="1143000" cy="3520440"/>
+          </a:xfrm>
+          <a:prstGeom prst="line">
+            <a:avLst/>
+          </a:prstGeom>
+          <a:ln w="12700">
+            <a:solidFill>
+              <a:srgbClr val="8A8A8A"/>
+            </a:solidFill>
+            <a:prstDash val="dash"/>
+          </a:ln>
+        </p:spPr>
+      </p:cxnSp>
+      <p:sp>
+        <p:nvSpPr>
+          <p:cNvPr id="105" name="Element 105"/>
+          <p:cNvSpPr/>
+          <p:nvPr/>
+        </p:nvSpPr>
+        <p:spPr>
+          <a:xfrm>
+            <a:off x="8229600" y="5257800"/>
+            <a:ext cx="731520" cy="384048"/>
+          </a:xfrm>
+          <a:prstGeom prst="roundRect">
+            <a:avLst/>
+          </a:prstGeom>
+          <a:noFill/>
+          <a:ln w="19050">
+            <a:solidFill>
+              <a:srgbClr val="404040"/>
+            </a:solidFill>
+          </a:ln>
+        </p:spPr>
+        <p:txBody>
+          <a:bodyPr wrap="square" lIns="0" tIns="0" rIns="0" bIns="0" anchor="ctr">
+            <a:noAutofit/>
+          </a:bodyPr>
+          <a:lstStyle/>
+          <a:p>
+            <a:pPr algn="ctr"/>
+            <a:r>
+              <a:rPr lang="pl-PL" sz="1100" b="0" dirty="0">
+                <a:solidFill>
+                  <a:srgbClr val="404040"/>
+                </a:solidFill>
+                <a:latin typeface="+mn-lt"/>
+              </a:rPr>
+              <a:t>kamera</a:t>
+            </a:r>
+          </a:p>
+        </p:txBody>
+      </p:sp>
+      <p:sp>
+        <p:nvSpPr>
+          <p:cNvPr id="106" name="Element 106"/>
+          <p:cNvSpPr/>
+          <p:nvPr/>
+        </p:nvSpPr>
+        <p:spPr>
+          <a:xfrm>
+            <a:off x="8092440" y="3108960"/>
+            <a:ext cx="1005840" cy="365760"/>
+          </a:xfrm>
+          <a:prstGeom prst="ellipse">
+            <a:avLst/>
+          </a:prstGeom>
+          <a:noFill/>
+          <a:ln w="19050">
+            <a:solidFill>
+              <a:srgbClr val="404040"/>
+            </a:solidFill>
+          </a:ln>
+        </p:spPr>
+        <p:txBody>
+          <a:bodyPr/>
+          <a:lstStyle/>
+          <a:p>
+            <a:endParaRPr lang="pl-PL"/>
+          </a:p>
+        </p:txBody>
+      </p:sp>
+      <p:sp>
+        <p:nvSpPr>
+          <p:cNvPr id="107" name="Element 107"/>
+          <p:cNvSpPr/>
+          <p:nvPr/>
+        </p:nvSpPr>
+        <p:spPr>
+          <a:xfrm>
+            <a:off x="8412480" y="3108960"/>
+            <a:ext cx="365760" cy="365760"/>
+          </a:xfrm>
+          <a:prstGeom prst="ellipse">
+            <a:avLst/>
+          </a:prstGeom>
+          <a:solidFill>
+            <a:srgbClr val="404040"/>
+          </a:solidFill>
+          <a:ln>
+            <a:noFill/>
+          </a:ln>
+        </p:spPr>
+        <p:txBody>
+          <a:bodyPr/>
+          <a:lstStyle/>
+          <a:p>
+            <a:endParaRPr lang="pl-PL"/>
+          </a:p>
+        </p:txBody>
+      </p:sp>
+      <p:sp>
+        <p:nvSpPr>
+          <p:cNvPr id="108" name="Element 108"/>
+          <p:cNvSpPr/>
+          <p:nvPr/>
+        </p:nvSpPr>
+        <p:spPr>
+          <a:xfrm rot="10800000">
+            <a:off x="8531352" y="3456432"/>
+            <a:ext cx="128016" cy="128016"/>
+          </a:xfrm>
+          <a:prstGeom prst="triangle">
+            <a:avLst/>
+          </a:prstGeom>
+          <a:solidFill>
+            <a:srgbClr val="E3B18D"/>
+          </a:solidFill>
+          <a:ln>
+            <a:noFill/>
+          </a:ln>
+        </p:spPr>
+        <p:txBody>
+          <a:bodyPr/>
+          <a:lstStyle/>
+          <a:p>
+            <a:endParaRPr lang="pl-PL"/>
+          </a:p>
+        </p:txBody>
+      </p:sp>
+      <p:cxnSp>
+        <p:nvCxnSpPr>
+          <p:cNvPr id="109" name="Strzałka 109"/>
+          <p:cNvCxnSpPr/>
+          <p:nvPr/>
+        </p:nvCxnSpPr>
+        <p:spPr>
+          <a:xfrm flipV="1">
+            <a:off x="7280579" y="3541794"/>
+            <a:ext cx="987919" cy="755467"/>
+          </a:xfrm>
+          <a:prstGeom prst="line">
+            <a:avLst/>
+          </a:prstGeom>
+          <a:ln w="19050">
+            <a:solidFill>
+              <a:srgbClr val="E3B18D"/>
+            </a:solidFill>
+            <a:tailEnd type="triangle"/>
+          </a:ln>
+        </p:spPr>
+      </p:cxnSp>
+      <p:sp>
+        <p:nvSpPr>
+          <p:cNvPr id="110" name="Element 110"/>
+          <p:cNvSpPr/>
+          <p:nvPr/>
+        </p:nvSpPr>
+        <p:spPr>
+          <a:xfrm>
+            <a:off x="6784848" y="4224528"/>
+            <a:ext cx="512064" cy="512064"/>
+          </a:xfrm>
+          <a:prstGeom prst="ellipse">
+            <a:avLst/>
+          </a:prstGeom>
+          <a:solidFill>
+            <a:srgbClr val="E3B18D"/>
+          </a:solidFill>
+          <a:ln>
+            <a:noFill/>
+          </a:ln>
+        </p:spPr>
+        <p:txBody>
+          <a:bodyPr/>
+          <a:lstStyle/>
+          <a:p>
+            <a:endParaRPr lang="pl-PL"/>
+          </a:p>
+        </p:txBody>
+      </p:sp>
+      <p:sp>
+        <p:nvSpPr>
+          <p:cNvPr id="111" name="Element 111"/>
+          <p:cNvSpPr/>
+          <p:nvPr/>
+        </p:nvSpPr>
+        <p:spPr>
+          <a:xfrm>
+            <a:off x="5029200" y="4297680"/>
+            <a:ext cx="1645920" cy="365760"/>
+          </a:xfrm>
+          <a:prstGeom prst="rect">
+            <a:avLst/>
+          </a:prstGeom>
+          <a:noFill/>
+          <a:ln>
+            <a:noFill/>
+          </a:ln>
+        </p:spPr>
+        <p:txBody>
+          <a:bodyPr wrap="square" lIns="0" tIns="0" rIns="0" bIns="0" anchor="ctr">
+            <a:noAutofit/>
+          </a:bodyPr>
+          <a:lstStyle/>
+          <a:p>
+            <a:pPr algn="r"/>
+            <a:r>
+              <a:rPr lang="pl-PL" sz="1600" b="1" dirty="0">
+                <a:solidFill>
+                  <a:srgbClr val="404040"/>
+                </a:solidFill>
+                <a:latin typeface="+mn-lt"/>
+              </a:rPr>
+              <a:t>Key</a:t>
+            </a:r>
+          </a:p>
+        </p:txBody>
+      </p:sp>
+      <p:cxnSp>
+        <p:nvCxnSpPr>
+          <p:cNvPr id="112" name="Strzałka 112"/>
+          <p:cNvCxnSpPr/>
+          <p:nvPr/>
+        </p:nvCxnSpPr>
+        <p:spPr>
+          <a:xfrm>
+            <a:off x="8943262" y="3511567"/>
+            <a:ext cx="1211642" cy="765247"/>
+          </a:xfrm>
+          <a:prstGeom prst="line">
+            <a:avLst/>
+          </a:prstGeom>
+          <a:ln w="19050">
+            <a:solidFill>
+              <a:srgbClr val="E3B18D"/>
+            </a:solidFill>
+            <a:tailEnd type="triangle"/>
+          </a:ln>
+        </p:spPr>
+      </p:cxnSp>
+      <p:sp>
+        <p:nvSpPr>
+          <p:cNvPr id="113" name="Element 113"/>
+          <p:cNvSpPr/>
+          <p:nvPr/>
+        </p:nvSpPr>
+        <p:spPr>
+          <a:xfrm>
+            <a:off x="10168128" y="4224528"/>
+            <a:ext cx="329184" cy="329184"/>
+          </a:xfrm>
+          <a:prstGeom prst="ellipse">
+            <a:avLst/>
+          </a:prstGeom>
+          <a:solidFill>
+            <a:srgbClr val="E3B18D"/>
+          </a:solidFill>
+          <a:ln>
+            <a:noFill/>
+          </a:ln>
+        </p:spPr>
+        <p:txBody>
+          <a:bodyPr/>
+          <a:lstStyle/>
+          <a:p>
+            <a:endParaRPr lang="pl-PL"/>
+          </a:p>
+        </p:txBody>
+      </p:sp>
+      <p:sp>
+        <p:nvSpPr>
+          <p:cNvPr id="114" name="Element 114"/>
+          <p:cNvSpPr/>
+          <p:nvPr/>
+        </p:nvSpPr>
+        <p:spPr>
+          <a:xfrm>
+            <a:off x="10607040" y="4206240"/>
+            <a:ext cx="1645920" cy="365760"/>
+          </a:xfrm>
+          <a:prstGeom prst="rect">
+            <a:avLst/>
+          </a:prstGeom>
+          <a:noFill/>
+          <a:ln>
+            <a:noFill/>
+          </a:ln>
+        </p:spPr>
+        <p:txBody>
+          <a:bodyPr wrap="square" lIns="0" tIns="0" rIns="0" bIns="0" anchor="ctr">
+            <a:noAutofit/>
+          </a:bodyPr>
+          <a:lstStyle/>
+          <a:p>
+            <a:pPr algn="l"/>
+            <a:r>
+              <a:rPr lang="pl-PL" sz="1600" b="1" dirty="0">
+                <a:solidFill>
+                  <a:srgbClr val="404040"/>
+                </a:solidFill>
+                <a:latin typeface="+mn-lt"/>
+              </a:rPr>
+              <a:t>Fill</a:t>
+            </a:r>
+          </a:p>
+        </p:txBody>
+      </p:sp>
+      <p:cxnSp>
+        <p:nvCxnSpPr>
+          <p:cNvPr id="115" name="Strzałka 115"/>
+          <p:cNvCxnSpPr/>
+          <p:nvPr/>
+        </p:nvCxnSpPr>
+        <p:spPr>
+          <a:xfrm flipV="1">
+            <a:off x="8846244" y="2298809"/>
+            <a:ext cx="512986" cy="666882"/>
+          </a:xfrm>
+          <a:prstGeom prst="line">
+            <a:avLst/>
+          </a:prstGeom>
+          <a:ln w="19050">
+            <a:solidFill>
+              <a:srgbClr val="E3B18D"/>
+            </a:solidFill>
+            <a:tailEnd type="triangle"/>
+          </a:ln>
+        </p:spPr>
+      </p:cxnSp>
+      <p:sp>
+        <p:nvSpPr>
+          <p:cNvPr id="116" name="Element 116"/>
+          <p:cNvSpPr/>
+          <p:nvPr/>
+        </p:nvSpPr>
+        <p:spPr>
+          <a:xfrm>
+            <a:off x="9308592" y="1901952"/>
+            <a:ext cx="402336" cy="402336"/>
+          </a:xfrm>
+          <a:prstGeom prst="ellipse">
+            <a:avLst/>
+          </a:prstGeom>
+          <a:solidFill>
+            <a:srgbClr val="E3B18D"/>
+          </a:solidFill>
+          <a:ln>
+            <a:noFill/>
+          </a:ln>
+        </p:spPr>
+        <p:txBody>
+          <a:bodyPr/>
+          <a:lstStyle/>
+          <a:p>
+            <a:endParaRPr lang="pl-PL"/>
+          </a:p>
+        </p:txBody>
+      </p:sp>
+      <p:sp>
+        <p:nvSpPr>
+          <p:cNvPr id="117" name="Element 117"/>
+          <p:cNvSpPr/>
+          <p:nvPr/>
+        </p:nvSpPr>
+        <p:spPr>
+          <a:xfrm>
+            <a:off x="9784080" y="1920240"/>
+            <a:ext cx="1645920" cy="365760"/>
+          </a:xfrm>
+          <a:prstGeom prst="rect">
+            <a:avLst/>
+          </a:prstGeom>
+          <a:noFill/>
+          <a:ln>
+            <a:noFill/>
+          </a:ln>
+        </p:spPr>
+        <p:txBody>
+          <a:bodyPr wrap="square" lIns="0" tIns="0" rIns="0" bIns="0" anchor="ctr">
+            <a:noAutofit/>
+          </a:bodyPr>
+          <a:lstStyle/>
+          <a:p>
+            <a:pPr algn="l"/>
+            <a:r>
+              <a:rPr lang="pl-PL" sz="1600" b="1" dirty="0">
+                <a:solidFill>
+                  <a:srgbClr val="404040"/>
+                </a:solidFill>
+                <a:latin typeface="+mn-lt"/>
+              </a:rPr>
+              <a:t>Rim / back</a:t>
+            </a:r>
+          </a:p>
+        </p:txBody>
+      </p:sp>
     </p:spTree>
     <p:extLst>
       <p:ext uri="{BB962C8B-B14F-4D97-AF65-F5344CB8AC3E}">
@@ -26684,30 +26845,171 @@
           </a:p>
         </p:txBody>
       </p:sp>
-      <p:sp>
-        <p:nvSpPr>
-          <p:cNvPr id="101" name="Element 101"/>
+      <p:cxnSp>
+        <p:nvCxnSpPr>
+          <p:cNvPr id="101" name="Linia 101"/>
+          <p:cNvCxnSpPr/>
+          <p:nvPr/>
+        </p:nvCxnSpPr>
+        <p:spPr>
+          <a:xfrm>
+            <a:off x="6217920" y="1554480"/>
+            <a:ext cx="4754880" cy="0"/>
+          </a:xfrm>
+          <a:prstGeom prst="line">
+            <a:avLst/>
+          </a:prstGeom>
+          <a:ln w="38100">
+            <a:solidFill>
+              <a:srgbClr val="404040"/>
+            </a:solidFill>
+          </a:ln>
+        </p:spPr>
+      </p:cxnSp>
+      <p:sp>
+        <p:nvSpPr>
+          <p:cNvPr id="102" name="Element 102"/>
           <p:cNvSpPr/>
           <p:nvPr/>
         </p:nvSpPr>
         <p:spPr>
           <a:xfrm>
-            <a:off x="6400800" y="1097280"/>
-            <a:ext cx="4389120" cy="4389120"/>
-          </a:xfrm>
-          <a:prstGeom prst="ellipse">
-            <a:avLst/>
-          </a:prstGeom>
-          <a:solidFill>
-            <a:srgbClr val="E3B18D">
-              <a:alpha val="10000"/>
-            </a:srgbClr>
-          </a:solidFill>
+            <a:off x="9692640" y="1143000"/>
+            <a:ext cx="1280160" cy="320040"/>
+          </a:xfrm>
+          <a:prstGeom prst="rect">
+            <a:avLst/>
+          </a:prstGeom>
+          <a:noFill/>
           <a:ln>
             <a:noFill/>
           </a:ln>
         </p:spPr>
         <p:txBody>
+          <a:bodyPr wrap="square" lIns="0" tIns="0" rIns="0" bIns="0" anchor="ctr">
+            <a:noAutofit/>
+          </a:bodyPr>
+          <a:lstStyle/>
+          <a:p>
+            <a:pPr algn="r"/>
+            <a:r>
+              <a:rPr lang="pl-PL" sz="1400" b="0" dirty="0">
+                <a:solidFill>
+                  <a:srgbClr val="8A8A8A"/>
+                </a:solidFill>
+                <a:latin typeface="+mn-lt"/>
+              </a:rPr>
+              <a:t>tło oświetlone</a:t>
+            </a:r>
+          </a:p>
+        </p:txBody>
+      </p:sp>
+      <p:cxnSp>
+        <p:nvCxnSpPr>
+          <p:cNvPr id="103" name="Linia 103"/>
+          <p:cNvCxnSpPr/>
+          <p:nvPr/>
+        </p:nvCxnSpPr>
+        <p:spPr>
+          <a:xfrm>
+            <a:off x="7223760" y="1737360"/>
+            <a:ext cx="1143000" cy="3520440"/>
+          </a:xfrm>
+          <a:prstGeom prst="line">
+            <a:avLst/>
+          </a:prstGeom>
+          <a:ln w="12700">
+            <a:solidFill>
+              <a:srgbClr val="8A8A8A"/>
+            </a:solidFill>
+            <a:prstDash val="dash"/>
+          </a:ln>
+        </p:spPr>
+      </p:cxnSp>
+      <p:cxnSp>
+        <p:nvCxnSpPr>
+          <p:cNvPr id="104" name="Linia 104"/>
+          <p:cNvCxnSpPr/>
+          <p:nvPr/>
+        </p:nvCxnSpPr>
+        <p:spPr>
+          <a:xfrm flipV="1">
+            <a:off x="8823960" y="1737360"/>
+            <a:ext cx="1143000" cy="3520440"/>
+          </a:xfrm>
+          <a:prstGeom prst="line">
+            <a:avLst/>
+          </a:prstGeom>
+          <a:ln w="12700">
+            <a:solidFill>
+              <a:srgbClr val="8A8A8A"/>
+            </a:solidFill>
+            <a:prstDash val="dash"/>
+          </a:ln>
+        </p:spPr>
+      </p:cxnSp>
+      <p:sp>
+        <p:nvSpPr>
+          <p:cNvPr id="105" name="Element 105"/>
+          <p:cNvSpPr/>
+          <p:nvPr/>
+        </p:nvSpPr>
+        <p:spPr>
+          <a:xfrm>
+            <a:off x="8229600" y="5257800"/>
+            <a:ext cx="731520" cy="384048"/>
+          </a:xfrm>
+          <a:prstGeom prst="roundRect">
+            <a:avLst/>
+          </a:prstGeom>
+          <a:noFill/>
+          <a:ln w="19050">
+            <a:solidFill>
+              <a:srgbClr val="404040"/>
+            </a:solidFill>
+          </a:ln>
+        </p:spPr>
+        <p:txBody>
+          <a:bodyPr wrap="square" lIns="0" tIns="0" rIns="0" bIns="0" anchor="ctr">
+            <a:noAutofit/>
+          </a:bodyPr>
+          <a:lstStyle/>
+          <a:p>
+            <a:pPr algn="ctr"/>
+            <a:r>
+              <a:rPr lang="pl-PL" sz="1100" b="0" dirty="0">
+                <a:solidFill>
+                  <a:srgbClr val="404040"/>
+                </a:solidFill>
+                <a:latin typeface="+mn-lt"/>
+              </a:rPr>
+              <a:t>kamera</a:t>
+            </a:r>
+          </a:p>
+        </p:txBody>
+      </p:sp>
+      <p:sp>
+        <p:nvSpPr>
+          <p:cNvPr id="106" name="Element 106"/>
+          <p:cNvSpPr/>
+          <p:nvPr/>
+        </p:nvSpPr>
+        <p:spPr>
+          <a:xfrm>
+            <a:off x="8092440" y="3108960"/>
+            <a:ext cx="1005840" cy="365760"/>
+          </a:xfrm>
+          <a:prstGeom prst="ellipse">
+            <a:avLst/>
+          </a:prstGeom>
+          <a:noFill/>
+          <a:ln w="19050">
+            <a:solidFill>
+              <a:srgbClr val="404040"/>
+            </a:solidFill>
+          </a:ln>
+        </p:spPr>
+        <p:txBody>
           <a:bodyPr/>
           <a:lstStyle/>
           <a:p>
@@ -26717,78 +27019,16 @@
       </p:sp>
       <p:sp>
         <p:nvSpPr>
-          <p:cNvPr id="102" name="Element 102"/>
+          <p:cNvPr id="107" name="Element 107"/>
           <p:cNvSpPr/>
           <p:nvPr/>
         </p:nvSpPr>
         <p:spPr>
           <a:xfrm>
-            <a:off x="6858000" y="1554480"/>
-            <a:ext cx="3474720" cy="3474720"/>
+            <a:off x="8412480" y="3108960"/>
+            <a:ext cx="365760" cy="365760"/>
           </a:xfrm>
           <a:prstGeom prst="ellipse">
-            <a:avLst/>
-          </a:prstGeom>
-          <a:solidFill>
-            <a:srgbClr val="E3B18D">
-              <a:alpha val="16000"/>
-            </a:srgbClr>
-          </a:solidFill>
-          <a:ln>
-            <a:noFill/>
-          </a:ln>
-        </p:spPr>
-        <p:txBody>
-          <a:bodyPr/>
-          <a:lstStyle/>
-          <a:p>
-            <a:endParaRPr lang="pl-PL"/>
-          </a:p>
-        </p:txBody>
-      </p:sp>
-      <p:sp>
-        <p:nvSpPr>
-          <p:cNvPr id="103" name="Element 103"/>
-          <p:cNvSpPr/>
-          <p:nvPr/>
-        </p:nvSpPr>
-        <p:spPr>
-          <a:xfrm>
-            <a:off x="7315200" y="2011680"/>
-            <a:ext cx="2560320" cy="2560320"/>
-          </a:xfrm>
-          <a:prstGeom prst="ellipse">
-            <a:avLst/>
-          </a:prstGeom>
-          <a:solidFill>
-            <a:srgbClr val="E3B18D">
-              <a:alpha val="24000"/>
-            </a:srgbClr>
-          </a:solidFill>
-          <a:ln>
-            <a:noFill/>
-          </a:ln>
-        </p:spPr>
-        <p:txBody>
-          <a:bodyPr/>
-          <a:lstStyle/>
-          <a:p>
-            <a:endParaRPr lang="pl-PL"/>
-          </a:p>
-        </p:txBody>
-      </p:sp>
-      <p:sp>
-        <p:nvSpPr>
-          <p:cNvPr id="104" name="Element 104"/>
-          <p:cNvSpPr/>
-          <p:nvPr/>
-        </p:nvSpPr>
-        <p:spPr>
-          <a:xfrm>
-            <a:off x="7406640" y="3840480"/>
-            <a:ext cx="2377440" cy="1554480"/>
-          </a:xfrm>
-          <a:prstGeom prst="round2SameRect">
             <a:avLst/>
           </a:prstGeom>
           <a:solidFill>
@@ -26808,20 +27048,20 @@
       </p:sp>
       <p:sp>
         <p:nvSpPr>
-          <p:cNvPr id="105" name="Element 105"/>
+          <p:cNvPr id="108" name="Element 108"/>
           <p:cNvSpPr/>
           <p:nvPr/>
         </p:nvSpPr>
         <p:spPr>
-          <a:xfrm>
-            <a:off x="7909560" y="2240280"/>
-            <a:ext cx="1371600" cy="1371600"/>
-          </a:xfrm>
-          <a:prstGeom prst="ellipse">
+          <a:xfrm rot="10800000">
+            <a:off x="8531352" y="3456432"/>
+            <a:ext cx="128016" cy="128016"/>
+          </a:xfrm>
+          <a:prstGeom prst="triangle">
             <a:avLst/>
           </a:prstGeom>
           <a:solidFill>
-            <a:srgbClr val="404040"/>
+            <a:srgbClr val="E3B18D"/>
           </a:solidFill>
           <a:ln>
             <a:noFill/>
@@ -26837,23 +27077,76 @@
       </p:sp>
       <p:sp>
         <p:nvSpPr>
-          <p:cNvPr id="106" name="Element 106"/>
+          <p:cNvPr id="109" name="Element 109"/>
           <p:cNvSpPr/>
           <p:nvPr/>
         </p:nvSpPr>
         <p:spPr>
           <a:xfrm>
-            <a:off x="7882128" y="2212848"/>
-            <a:ext cx="1426464" cy="1426464"/>
-          </a:xfrm>
-          <a:prstGeom prst="ellipse">
-            <a:avLst/>
-          </a:prstGeom>
-          <a:noFill/>
-          <a:ln w="31750">
+            <a:off x="6217920" y="1417320"/>
+            <a:ext cx="4754880" cy="457200"/>
+          </a:xfrm>
+          <a:prstGeom prst="rect">
+            <a:avLst/>
+          </a:prstGeom>
+          <a:solidFill>
+            <a:srgbClr val="E3B18D">
+              <a:alpha val="45000"/>
+            </a:srgbClr>
+          </a:solidFill>
+          <a:ln>
+            <a:noFill/>
+          </a:ln>
+        </p:spPr>
+        <p:txBody>
+          <a:bodyPr/>
+          <a:lstStyle/>
+          <a:p>
+            <a:endParaRPr lang="pl-PL"/>
+          </a:p>
+        </p:txBody>
+      </p:sp>
+      <p:cxnSp>
+        <p:nvCxnSpPr>
+          <p:cNvPr id="110" name="Strzałka 110"/>
+          <p:cNvCxnSpPr/>
+          <p:nvPr/>
+        </p:nvCxnSpPr>
+        <p:spPr>
+          <a:xfrm flipV="1">
+            <a:off x="6546013" y="2070139"/>
+            <a:ext cx="344287" cy="473394"/>
+          </a:xfrm>
+          <a:prstGeom prst="line">
+            <a:avLst/>
+          </a:prstGeom>
+          <a:ln w="19050">
             <a:solidFill>
               <a:srgbClr val="E3B18D"/>
             </a:solidFill>
+            <a:tailEnd type="triangle"/>
+          </a:ln>
+        </p:spPr>
+      </p:cxnSp>
+      <p:sp>
+        <p:nvSpPr>
+          <p:cNvPr id="111" name="Element 111"/>
+          <p:cNvSpPr/>
+          <p:nvPr/>
+        </p:nvSpPr>
+        <p:spPr>
+          <a:xfrm>
+            <a:off x="6199632" y="2542032"/>
+            <a:ext cx="402336" cy="402336"/>
+          </a:xfrm>
+          <a:prstGeom prst="ellipse">
+            <a:avLst/>
+          </a:prstGeom>
+          <a:solidFill>
+            <a:srgbClr val="E3B18D"/>
+          </a:solidFill>
+          <a:ln>
+            <a:noFill/>
           </a:ln>
         </p:spPr>
         <p:txBody>
@@ -26866,14 +27159,14 @@
       </p:sp>
       <p:sp>
         <p:nvSpPr>
-          <p:cNvPr id="107" name="Element 107"/>
+          <p:cNvPr id="112" name="Element 112"/>
           <p:cNvSpPr/>
           <p:nvPr/>
         </p:nvSpPr>
         <p:spPr>
           <a:xfrm>
-            <a:off x="7223760" y="5623560"/>
-            <a:ext cx="2743200" cy="365760"/>
+            <a:off x="5577840" y="2194560"/>
+            <a:ext cx="1645920" cy="365760"/>
           </a:xfrm>
           <a:prstGeom prst="rect">
             <a:avLst/>
@@ -26891,13 +27184,178 @@
           <a:p>
             <a:pPr algn="ctr"/>
             <a:r>
-              <a:rPr lang="pl-PL" sz="1600" b="0" dirty="0">
-                <a:solidFill>
-                  <a:srgbClr val="8A8A8A"/>
+              <a:rPr lang="pl-PL" sz="1600" b="1" dirty="0">
+                <a:solidFill>
+                  <a:srgbClr val="404040"/>
                 </a:solidFill>
                 <a:latin typeface="+mn-lt"/>
               </a:rPr>
-              <a:t>światło za postacią</a:t>
+              <a:t/>
+            </a:r>
+          </a:p>
+        </p:txBody>
+      </p:sp>
+      <p:cxnSp>
+        <p:nvCxnSpPr>
+          <p:cNvPr id="113" name="Strzałka 113"/>
+          <p:cNvCxnSpPr/>
+          <p:nvPr/>
+        </p:nvCxnSpPr>
+        <p:spPr>
+          <a:xfrm>
+            <a:off x="10300421" y="2070139"/>
+            <a:ext cx="344287" cy="473394"/>
+          </a:xfrm>
+          <a:prstGeom prst="line">
+            <a:avLst/>
+          </a:prstGeom>
+          <a:ln w="19050">
+            <a:solidFill>
+              <a:srgbClr val="E3B18D"/>
+            </a:solidFill>
+            <a:tailEnd type="triangle"/>
+          </a:ln>
+        </p:spPr>
+      </p:cxnSp>
+      <p:sp>
+        <p:nvSpPr>
+          <p:cNvPr id="114" name="Element 114"/>
+          <p:cNvSpPr/>
+          <p:nvPr/>
+        </p:nvSpPr>
+        <p:spPr>
+          <a:xfrm>
+            <a:off x="10588752" y="2542032"/>
+            <a:ext cx="402336" cy="402336"/>
+          </a:xfrm>
+          <a:prstGeom prst="ellipse">
+            <a:avLst/>
+          </a:prstGeom>
+          <a:solidFill>
+            <a:srgbClr val="E3B18D"/>
+          </a:solidFill>
+          <a:ln>
+            <a:noFill/>
+          </a:ln>
+        </p:spPr>
+        <p:txBody>
+          <a:bodyPr/>
+          <a:lstStyle/>
+          <a:p>
+            <a:endParaRPr lang="pl-PL"/>
+          </a:p>
+        </p:txBody>
+      </p:sp>
+      <p:sp>
+        <p:nvSpPr>
+          <p:cNvPr id="115" name="Element 115"/>
+          <p:cNvSpPr/>
+          <p:nvPr/>
+        </p:nvSpPr>
+        <p:spPr>
+          <a:xfrm>
+            <a:off x="9966960" y="2194560"/>
+            <a:ext cx="1645920" cy="365760"/>
+          </a:xfrm>
+          <a:prstGeom prst="rect">
+            <a:avLst/>
+          </a:prstGeom>
+          <a:noFill/>
+          <a:ln>
+            <a:noFill/>
+          </a:ln>
+        </p:spPr>
+        <p:txBody>
+          <a:bodyPr wrap="square" lIns="0" tIns="0" rIns="0" bIns="0" anchor="ctr">
+            <a:noAutofit/>
+          </a:bodyPr>
+          <a:lstStyle/>
+          <a:p>
+            <a:pPr algn="ctr"/>
+            <a:r>
+              <a:rPr lang="pl-PL" sz="1600" b="1" dirty="0">
+                <a:solidFill>
+                  <a:srgbClr val="404040"/>
+                </a:solidFill>
+                <a:latin typeface="+mn-lt"/>
+              </a:rPr>
+              <a:t/>
+            </a:r>
+          </a:p>
+        </p:txBody>
+      </p:sp>
+      <p:sp>
+        <p:nvSpPr>
+          <p:cNvPr id="116" name="Element 116"/>
+          <p:cNvSpPr/>
+          <p:nvPr/>
+        </p:nvSpPr>
+        <p:spPr>
+          <a:xfrm>
+            <a:off x="5029200" y="3063240"/>
+            <a:ext cx="1737360" cy="365760"/>
+          </a:xfrm>
+          <a:prstGeom prst="rect">
+            <a:avLst/>
+          </a:prstGeom>
+          <a:noFill/>
+          <a:ln>
+            <a:noFill/>
+          </a:ln>
+        </p:spPr>
+        <p:txBody>
+          <a:bodyPr wrap="square" lIns="0" tIns="0" rIns="0" bIns="0" anchor="ctr">
+            <a:noAutofit/>
+          </a:bodyPr>
+          <a:lstStyle/>
+          <a:p>
+            <a:pPr algn="r"/>
+            <a:r>
+              <a:rPr lang="pl-PL" sz="1400" b="0" dirty="0">
+                <a:solidFill>
+                  <a:srgbClr val="8A8A8A"/>
+                </a:solidFill>
+                <a:latin typeface="+mn-lt"/>
+              </a:rPr>
+              <a:t>światło na tło</a:t>
+            </a:r>
+          </a:p>
+        </p:txBody>
+      </p:sp>
+      <p:sp>
+        <p:nvSpPr>
+          <p:cNvPr id="117" name="Element 117"/>
+          <p:cNvSpPr/>
+          <p:nvPr/>
+        </p:nvSpPr>
+        <p:spPr>
+          <a:xfrm>
+            <a:off x="9646920" y="3749040"/>
+            <a:ext cx="2103120" cy="365760"/>
+          </a:xfrm>
+          <a:prstGeom prst="rect">
+            <a:avLst/>
+          </a:prstGeom>
+          <a:noFill/>
+          <a:ln>
+            <a:noFill/>
+          </a:ln>
+        </p:spPr>
+        <p:txBody>
+          <a:bodyPr wrap="square" lIns="0" tIns="0" rIns="0" bIns="0" anchor="ctr">
+            <a:noAutofit/>
+          </a:bodyPr>
+          <a:lstStyle/>
+          <a:p>
+            <a:pPr algn="l"/>
+            <a:r>
+              <a:rPr lang="pl-PL" sz="1400" b="0" dirty="0">
+                <a:solidFill>
+                  <a:srgbClr val="8A8A8A"/>
+                </a:solidFill>
+                <a:latin typeface="+mn-lt"/>
+              </a:rPr>
+              <a:t>postać bez światła</a:t>
             </a:r>
           </a:p>
         </p:txBody>
@@ -27059,18 +27517,219 @@
           </a:p>
         </p:txBody>
       </p:sp>
-      <p:sp>
-        <p:nvSpPr>
-          <p:cNvPr id="101" name="Element 101"/>
+      <p:cxnSp>
+        <p:nvCxnSpPr>
+          <p:cNvPr id="101" name="Linia 101"/>
+          <p:cNvCxnSpPr/>
+          <p:nvPr/>
+        </p:nvCxnSpPr>
+        <p:spPr>
+          <a:xfrm>
+            <a:off x="6217920" y="1554480"/>
+            <a:ext cx="4754880" cy="0"/>
+          </a:xfrm>
+          <a:prstGeom prst="line">
+            <a:avLst/>
+          </a:prstGeom>
+          <a:ln w="38100">
+            <a:solidFill>
+              <a:srgbClr val="404040"/>
+            </a:solidFill>
+          </a:ln>
+        </p:spPr>
+      </p:cxnSp>
+      <p:sp>
+        <p:nvSpPr>
+          <p:cNvPr id="102" name="Element 102"/>
           <p:cNvSpPr/>
           <p:nvPr/>
         </p:nvSpPr>
         <p:spPr>
           <a:xfrm>
-            <a:off x="6675120" y="1463040"/>
-            <a:ext cx="548640" cy="548640"/>
+            <a:off x="9692640" y="1143000"/>
+            <a:ext cx="1280160" cy="320040"/>
+          </a:xfrm>
+          <a:prstGeom prst="rect">
+            <a:avLst/>
+          </a:prstGeom>
+          <a:noFill/>
+          <a:ln>
+            <a:noFill/>
+          </a:ln>
+        </p:spPr>
+        <p:txBody>
+          <a:bodyPr wrap="square" lIns="0" tIns="0" rIns="0" bIns="0" anchor="ctr">
+            <a:noAutofit/>
+          </a:bodyPr>
+          <a:lstStyle/>
+          <a:p>
+            <a:pPr algn="r"/>
+            <a:r>
+              <a:rPr lang="pl-PL" sz="1400" b="0" dirty="0">
+                <a:solidFill>
+                  <a:srgbClr val="8A8A8A"/>
+                </a:solidFill>
+                <a:latin typeface="+mn-lt"/>
+              </a:rPr>
+              <a:t>tło</a:t>
+            </a:r>
+          </a:p>
+        </p:txBody>
+      </p:sp>
+      <p:cxnSp>
+        <p:nvCxnSpPr>
+          <p:cNvPr id="103" name="Linia 103"/>
+          <p:cNvCxnSpPr/>
+          <p:nvPr/>
+        </p:nvCxnSpPr>
+        <p:spPr>
+          <a:xfrm>
+            <a:off x="7223760" y="1737360"/>
+            <a:ext cx="1143000" cy="3520440"/>
+          </a:xfrm>
+          <a:prstGeom prst="line">
+            <a:avLst/>
+          </a:prstGeom>
+          <a:ln w="12700">
+            <a:solidFill>
+              <a:srgbClr val="8A8A8A"/>
+            </a:solidFill>
+            <a:prstDash val="dash"/>
+          </a:ln>
+        </p:spPr>
+      </p:cxnSp>
+      <p:cxnSp>
+        <p:nvCxnSpPr>
+          <p:cNvPr id="104" name="Linia 104"/>
+          <p:cNvCxnSpPr/>
+          <p:nvPr/>
+        </p:nvCxnSpPr>
+        <p:spPr>
+          <a:xfrm flipV="1">
+            <a:off x="8823960" y="1737360"/>
+            <a:ext cx="1143000" cy="3520440"/>
+          </a:xfrm>
+          <a:prstGeom prst="line">
+            <a:avLst/>
+          </a:prstGeom>
+          <a:ln w="12700">
+            <a:solidFill>
+              <a:srgbClr val="8A8A8A"/>
+            </a:solidFill>
+            <a:prstDash val="dash"/>
+          </a:ln>
+        </p:spPr>
+      </p:cxnSp>
+      <p:sp>
+        <p:nvSpPr>
+          <p:cNvPr id="105" name="Element 105"/>
+          <p:cNvSpPr/>
+          <p:nvPr/>
+        </p:nvSpPr>
+        <p:spPr>
+          <a:xfrm>
+            <a:off x="8229600" y="5257800"/>
+            <a:ext cx="731520" cy="384048"/>
+          </a:xfrm>
+          <a:prstGeom prst="roundRect">
+            <a:avLst/>
+          </a:prstGeom>
+          <a:noFill/>
+          <a:ln w="19050">
+            <a:solidFill>
+              <a:srgbClr val="404040"/>
+            </a:solidFill>
+          </a:ln>
+        </p:spPr>
+        <p:txBody>
+          <a:bodyPr wrap="square" lIns="0" tIns="0" rIns="0" bIns="0" anchor="ctr">
+            <a:noAutofit/>
+          </a:bodyPr>
+          <a:lstStyle/>
+          <a:p>
+            <a:pPr algn="ctr"/>
+            <a:r>
+              <a:rPr lang="pl-PL" sz="1100" b="0" dirty="0">
+                <a:solidFill>
+                  <a:srgbClr val="404040"/>
+                </a:solidFill>
+                <a:latin typeface="+mn-lt"/>
+              </a:rPr>
+              <a:t>kamera</a:t>
+            </a:r>
+          </a:p>
+        </p:txBody>
+      </p:sp>
+      <p:sp>
+        <p:nvSpPr>
+          <p:cNvPr id="106" name="Element 106"/>
+          <p:cNvSpPr/>
+          <p:nvPr/>
+        </p:nvSpPr>
+        <p:spPr>
+          <a:xfrm>
+            <a:off x="8092440" y="3108960"/>
+            <a:ext cx="1005840" cy="365760"/>
           </a:xfrm>
           <a:prstGeom prst="ellipse">
+            <a:avLst/>
+          </a:prstGeom>
+          <a:noFill/>
+          <a:ln w="19050">
+            <a:solidFill>
+              <a:srgbClr val="404040"/>
+            </a:solidFill>
+          </a:ln>
+        </p:spPr>
+        <p:txBody>
+          <a:bodyPr/>
+          <a:lstStyle/>
+          <a:p>
+            <a:endParaRPr lang="pl-PL"/>
+          </a:p>
+        </p:txBody>
+      </p:sp>
+      <p:sp>
+        <p:nvSpPr>
+          <p:cNvPr id="107" name="Element 107"/>
+          <p:cNvSpPr/>
+          <p:nvPr/>
+        </p:nvSpPr>
+        <p:spPr>
+          <a:xfrm>
+            <a:off x="8412480" y="3108960"/>
+            <a:ext cx="365760" cy="365760"/>
+          </a:xfrm>
+          <a:prstGeom prst="ellipse">
+            <a:avLst/>
+          </a:prstGeom>
+          <a:solidFill>
+            <a:srgbClr val="404040"/>
+          </a:solidFill>
+          <a:ln>
+            <a:noFill/>
+          </a:ln>
+        </p:spPr>
+        <p:txBody>
+          <a:bodyPr/>
+          <a:lstStyle/>
+          <a:p>
+            <a:endParaRPr lang="pl-PL"/>
+          </a:p>
+        </p:txBody>
+      </p:sp>
+      <p:sp>
+        <p:nvSpPr>
+          <p:cNvPr id="108" name="Element 108"/>
+          <p:cNvSpPr/>
+          <p:nvPr/>
+        </p:nvSpPr>
+        <p:spPr>
+          <a:xfrm rot="10800000">
+            <a:off x="8531352" y="3456432"/>
+            <a:ext cx="128016" cy="128016"/>
+          </a:xfrm>
+          <a:prstGeom prst="triangle">
             <a:avLst/>
           </a:prstGeom>
           <a:solidFill>
@@ -27088,230 +27747,40 @@
           </a:p>
         </p:txBody>
       </p:sp>
-      <p:sp>
-        <p:nvSpPr>
-          <p:cNvPr id="102" name="Element 102"/>
-          <p:cNvSpPr/>
-          <p:nvPr/>
-        </p:nvSpPr>
-        <p:spPr>
-          <a:xfrm>
-            <a:off x="6309360" y="2103120"/>
-            <a:ext cx="1371600" cy="365760"/>
-          </a:xfrm>
-          <a:prstGeom prst="rect">
-            <a:avLst/>
-          </a:prstGeom>
-          <a:noFill/>
-          <a:ln>
-            <a:noFill/>
-          </a:ln>
-        </p:spPr>
-        <p:txBody>
-          <a:bodyPr wrap="square" lIns="0" tIns="0" rIns="0" bIns="0" anchor="ctr">
-            <a:noAutofit/>
-          </a:bodyPr>
-          <a:lstStyle/>
-          <a:p>
-            <a:pPr algn="ctr"/>
-            <a:r>
-              <a:rPr lang="pl-PL" sz="1400" b="0" dirty="0">
-                <a:solidFill>
-                  <a:srgbClr val="8A8A8A"/>
-                </a:solidFill>
-                <a:latin typeface="+mn-lt"/>
-              </a:rPr>
-              <a:t>światło</a:t>
-            </a:r>
-          </a:p>
-        </p:txBody>
-      </p:sp>
       <p:cxnSp>
         <p:nvCxnSpPr>
-          <p:cNvPr id="103" name="Linia 103"/>
+          <p:cNvPr id="109" name="Strzałka 109"/>
           <p:cNvCxnSpPr/>
           <p:nvPr/>
         </p:nvCxnSpPr>
         <p:spPr>
-          <a:xfrm>
-            <a:off x="7223760" y="1920240"/>
-            <a:ext cx="960120" cy="548640"/>
+          <a:xfrm flipV="1">
+            <a:off x="7254251" y="3582800"/>
+            <a:ext cx="1050149" cy="1050149"/>
           </a:xfrm>
           <a:prstGeom prst="line">
             <a:avLst/>
           </a:prstGeom>
-          <a:ln w="15875">
+          <a:ln w="19050">
             <a:solidFill>
               <a:srgbClr val="E3B18D"/>
             </a:solidFill>
-            <a:prstDash val="dash"/>
+            <a:tailEnd type="triangle"/>
           </a:ln>
         </p:spPr>
       </p:cxnSp>
       <p:sp>
         <p:nvSpPr>
-          <p:cNvPr id="104" name="Element 104"/>
+          <p:cNvPr id="110" name="Element 110"/>
           <p:cNvSpPr/>
           <p:nvPr/>
         </p:nvSpPr>
         <p:spPr>
           <a:xfrm>
-            <a:off x="7498080" y="4434840"/>
-            <a:ext cx="2743200" cy="1097280"/>
-          </a:xfrm>
-          <a:prstGeom prst="round2SameRect">
-            <a:avLst/>
-          </a:prstGeom>
-          <a:noFill/>
-          <a:ln w="22225">
-            <a:solidFill>
-              <a:srgbClr val="404040"/>
-            </a:solidFill>
-          </a:ln>
-        </p:spPr>
-        <p:txBody>
-          <a:bodyPr/>
-          <a:lstStyle/>
-          <a:p>
-            <a:endParaRPr lang="pl-PL"/>
-          </a:p>
-        </p:txBody>
-      </p:sp>
-      <p:sp>
-        <p:nvSpPr>
-          <p:cNvPr id="105" name="Element 105"/>
-          <p:cNvSpPr/>
-          <p:nvPr/>
-        </p:nvSpPr>
-        <p:spPr>
-          <a:xfrm>
-            <a:off x="7726680" y="2057400"/>
-            <a:ext cx="2286000" cy="2286000"/>
+            <a:off x="6784848" y="4590288"/>
+            <a:ext cx="512064" cy="512064"/>
           </a:xfrm>
           <a:prstGeom prst="ellipse">
-            <a:avLst/>
-          </a:prstGeom>
-          <a:solidFill>
-            <a:srgbClr val="FFFFFF"/>
-          </a:solidFill>
-          <a:ln w="22225">
-            <a:solidFill>
-              <a:srgbClr val="404040"/>
-            </a:solidFill>
-          </a:ln>
-        </p:spPr>
-        <p:txBody>
-          <a:bodyPr/>
-          <a:lstStyle/>
-          <a:p>
-            <a:endParaRPr lang="pl-PL"/>
-          </a:p>
-        </p:txBody>
-      </p:sp>
-      <p:sp>
-        <p:nvSpPr>
-          <p:cNvPr id="106" name="Element 106"/>
-          <p:cNvSpPr/>
-          <p:nvPr/>
-        </p:nvSpPr>
-        <p:spPr>
-          <a:xfrm>
-            <a:off x="7726680" y="2057400"/>
-            <a:ext cx="2286000" cy="2286000"/>
-          </a:xfrm>
-          <a:prstGeom prst="pie">
-            <a:avLst>
-              <a:gd name="adj1" fmla="val 16200000"/>
-              <a:gd name="adj2" fmla="val 5400000"/>
-            </a:avLst>
-          </a:prstGeom>
-          <a:solidFill>
-            <a:srgbClr val="404040">
-              <a:alpha val="35000"/>
-            </a:srgbClr>
-          </a:solidFill>
-          <a:ln>
-            <a:noFill/>
-          </a:ln>
-        </p:spPr>
-        <p:txBody>
-          <a:bodyPr/>
-          <a:lstStyle/>
-          <a:p>
-            <a:endParaRPr lang="pl-PL"/>
-          </a:p>
-        </p:txBody>
-      </p:sp>
-      <p:sp>
-        <p:nvSpPr>
-          <p:cNvPr id="107" name="Element 107"/>
-          <p:cNvSpPr/>
-          <p:nvPr/>
-        </p:nvSpPr>
-        <p:spPr>
-          <a:xfrm>
-            <a:off x="8394192" y="2907792"/>
-            <a:ext cx="128016" cy="128016"/>
-          </a:xfrm>
-          <a:prstGeom prst="ellipse">
-            <a:avLst/>
-          </a:prstGeom>
-          <a:solidFill>
-            <a:srgbClr val="404040"/>
-          </a:solidFill>
-          <a:ln>
-            <a:noFill/>
-          </a:ln>
-        </p:spPr>
-        <p:txBody>
-          <a:bodyPr/>
-          <a:lstStyle/>
-          <a:p>
-            <a:endParaRPr lang="pl-PL"/>
-          </a:p>
-        </p:txBody>
-      </p:sp>
-      <p:sp>
-        <p:nvSpPr>
-          <p:cNvPr id="108" name="Element 108"/>
-          <p:cNvSpPr/>
-          <p:nvPr/>
-        </p:nvSpPr>
-        <p:spPr>
-          <a:xfrm>
-            <a:off x="9217152" y="2907792"/>
-            <a:ext cx="128016" cy="128016"/>
-          </a:xfrm>
-          <a:prstGeom prst="ellipse">
-            <a:avLst/>
-          </a:prstGeom>
-          <a:solidFill>
-            <a:srgbClr val="404040"/>
-          </a:solidFill>
-          <a:ln>
-            <a:noFill/>
-          </a:ln>
-        </p:spPr>
-        <p:txBody>
-          <a:bodyPr/>
-          <a:lstStyle/>
-          <a:p>
-            <a:endParaRPr lang="pl-PL"/>
-          </a:p>
-        </p:txBody>
-      </p:sp>
-      <p:sp>
-        <p:nvSpPr>
-          <p:cNvPr id="109" name="Element 109"/>
-          <p:cNvSpPr/>
-          <p:nvPr/>
-        </p:nvSpPr>
-        <p:spPr>
-          <a:xfrm rot="10800000">
-            <a:off x="9189720" y="3200400"/>
-            <a:ext cx="365760" cy="365760"/>
-          </a:xfrm>
-          <a:prstGeom prst="triangle">
             <a:avLst/>
           </a:prstGeom>
           <a:solidFill>
@@ -27331,14 +27800,14 @@
       </p:sp>
       <p:sp>
         <p:nvSpPr>
-          <p:cNvPr id="110" name="Element 110"/>
+          <p:cNvPr id="111" name="Element 111"/>
           <p:cNvSpPr/>
           <p:nvPr/>
         </p:nvSpPr>
         <p:spPr>
           <a:xfrm>
-            <a:off x="10195560" y="3337560"/>
-            <a:ext cx="2011680" cy="365760"/>
+            <a:off x="5029200" y="4663440"/>
+            <a:ext cx="1645920" cy="365760"/>
           </a:xfrm>
           <a:prstGeom prst="rect">
             <a:avLst/>
@@ -27354,40 +27823,19 @@
           </a:bodyPr>
           <a:lstStyle/>
           <a:p>
-            <a:pPr algn="l"/>
-            <a:r>
-              <a:rPr lang="pl-PL" sz="1400" b="0" dirty="0">
-                <a:solidFill>
-                  <a:srgbClr val="8A8A8A"/>
+            <a:pPr algn="r"/>
+            <a:r>
+              <a:rPr lang="pl-PL" sz="1600" b="1" dirty="0">
+                <a:solidFill>
+                  <a:srgbClr val="404040"/>
                 </a:solidFill>
                 <a:latin typeface="+mn-lt"/>
               </a:rPr>
-              <a:t>trójkąt pod okiem</a:t>
-            </a:r>
-          </a:p>
-        </p:txBody>
-      </p:sp>
-      <p:cxnSp>
-        <p:nvCxnSpPr>
-          <p:cNvPr id="111" name="Linia 111"/>
-          <p:cNvCxnSpPr/>
-          <p:nvPr/>
-        </p:nvCxnSpPr>
-        <p:spPr>
-          <a:xfrm>
-            <a:off x="9555480" y="3337560"/>
-            <a:ext cx="594360" cy="137160"/>
-          </a:xfrm>
-          <a:prstGeom prst="line">
-            <a:avLst/>
-          </a:prstGeom>
-          <a:ln w="12700">
-            <a:solidFill>
-              <a:srgbClr val="8A8A8A"/>
-            </a:solidFill>
-          </a:ln>
-        </p:spPr>
-      </p:cxnSp>
+              <a:t>Key</a:t>
+            </a:r>
+          </a:p>
+        </p:txBody>
+      </p:sp>
       <p:sp>
         <p:nvSpPr>
           <p:cNvPr id="112" name="Element 112"/>
@@ -27396,8 +27844,8 @@
         </p:nvSpPr>
         <p:spPr>
           <a:xfrm>
-            <a:off x="10195560" y="2286000"/>
-            <a:ext cx="2011680" cy="365760"/>
+            <a:off x="4754880" y="5074920"/>
+            <a:ext cx="2377440" cy="365760"/>
           </a:xfrm>
           <a:prstGeom prst="rect">
             <a:avLst/>
@@ -27413,7 +27861,7 @@
           </a:bodyPr>
           <a:lstStyle/>
           <a:p>
-            <a:pPr algn="l"/>
+            <a:pPr algn="r"/>
             <a:r>
               <a:rPr lang="pl-PL" sz="1400" b="0" dirty="0">
                 <a:solidFill>
@@ -27421,7 +27869,45 @@
                 </a:solidFill>
                 <a:latin typeface="+mn-lt"/>
               </a:rPr>
-              <a:t>cień</a:t>
+              <a:t>~45° z boku i z góry</a:t>
+            </a:r>
+          </a:p>
+        </p:txBody>
+      </p:sp>
+      <p:sp>
+        <p:nvSpPr>
+          <p:cNvPr id="113" name="Element 113"/>
+          <p:cNvSpPr/>
+          <p:nvPr/>
+        </p:nvSpPr>
+        <p:spPr>
+          <a:xfrm>
+            <a:off x="9646920" y="3108960"/>
+            <a:ext cx="2103120" cy="365760"/>
+          </a:xfrm>
+          <a:prstGeom prst="rect">
+            <a:avLst/>
+          </a:prstGeom>
+          <a:noFill/>
+          <a:ln>
+            <a:noFill/>
+          </a:ln>
+        </p:spPr>
+        <p:txBody>
+          <a:bodyPr wrap="square" lIns="0" tIns="0" rIns="0" bIns="0" anchor="ctr">
+            <a:noAutofit/>
+          </a:bodyPr>
+          <a:lstStyle/>
+          <a:p>
+            <a:pPr algn="l"/>
+            <a:r>
+              <a:rPr lang="pl-PL" sz="1400" b="0" dirty="0">
+                <a:solidFill>
+                  <a:srgbClr val="8A8A8A"/>
+                </a:solidFill>
+                <a:latin typeface="+mn-lt"/>
+              </a:rPr>
+              <a:t>cień po drugiej stronie</a:t>
             </a:r>
           </a:p>
         </p:txBody>

</xml_diff>